<commit_message>
docs: results of the v3 policy at 120k steps; slides and narration rebuilt
Co-Authored-By: Claude Opus 5 <noreply@anthropic.com>
</commit_message>
<xml_diff>
--- a/docs/slides/table_for_two.pptx
+++ b/docs/slides/table_for_two.pptx
@@ -229,16 +229,16 @@
                 <c:formatCode>General</c:formatCode>
                 <c:ptCount val="4"/>
                 <c:pt idx="0">
-                  <c:v>8.2</c:v>
+                  <c:v>13.7</c:v>
                 </c:pt>
                 <c:pt idx="1">
-                  <c:v>10.1</c:v>
+                  <c:v>13.8</c:v>
                 </c:pt>
                 <c:pt idx="2">
-                  <c:v>5.9</c:v>
+                  <c:v>4.9</c:v>
                 </c:pt>
                 <c:pt idx="3">
-                  <c:v>15.8</c:v>
+                  <c:v>16.5</c:v>
                 </c:pt>
               </c:numCache>
             </c:numRef>
@@ -1775,7 +1775,7 @@
       </p:grpSpPr>
       <p:pic>
         <p:nvPicPr>
-          <p:cNvPr id="2" name="Image 0" descr="G:\2026claude\bimanual-vla\out\cover.png">    </p:cNvPr>
+          <p:cNvPr id="2" name="Image 0" descr="C:\Users\ASUS\bimanual-vla\out\cover.png">    </p:cNvPr>
           <p:cNvPicPr>
             <a:picLocks noChangeAspect="1"/>
           </p:cNvPicPr>
@@ -2021,7 +2021,7 @@
                 <a:ea typeface="Calibri" pitchFamily="34" charset="-122"/>
                 <a:cs typeface="Calibri" pitchFamily="34" charset="-120"/>
               </a:rPr>
-              <a:t>Open the drawer and take out the spoon and fork</a:t>
+              <a:t>The brief: drawer, spoon and fork, plate on the placemat, an arm-to-arm hand-over, one arm holds the mug while the other pours</a:t>
             </a:r>
             <a:endParaRPr lang="en-US" sz="1600" dirty="0"/>
           </a:p>
@@ -2042,7 +2042,7 @@
                 <a:ea typeface="Calibri" pitchFamily="34" charset="-122"/>
                 <a:cs typeface="Calibri" pitchFamily="34" charset="-120"/>
               </a:rPr>
-              <a:t>Hand the fork from one arm to the other</a:t>
+              <a:t>What we built: both arms carry the plate, the spoon is handed over, the mug stands on the table while the other arm pours (reach — slide 7)</a:t>
             </a:r>
             <a:endParaRPr lang="en-US" sz="1600" dirty="0"/>
           </a:p>
@@ -2063,7 +2063,7 @@
                 <a:ea typeface="Calibri" pitchFamily="34" charset="-122"/>
                 <a:cs typeface="Calibri" pitchFamily="34" charset="-120"/>
               </a:rPr>
-              <a:t>Put the plate on the placemat</a:t>
+              <a:t>Every object held by finger contact and friction only; the water is 24 beads</a:t>
             </a:r>
             <a:endParaRPr lang="en-US" sz="1600" dirty="0"/>
           </a:p>
@@ -2084,7 +2084,7 @@
                 <a:ea typeface="Calibri" pitchFamily="34" charset="-122"/>
                 <a:cs typeface="Calibri" pitchFamily="34" charset="-120"/>
               </a:rPr>
-              <a:t>Hold the mug with one arm while the other pours from the bottle</a:t>
+              <a:t>Follow a natural-language instruction; see the scene through cameras</a:t>
             </a:r>
             <a:endParaRPr lang="en-US" sz="1600" dirty="0"/>
           </a:p>
@@ -2105,27 +2105,6 @@
                 <a:ea typeface="Calibri" pitchFamily="34" charset="-122"/>
                 <a:cs typeface="Calibri" pitchFamily="34" charset="-120"/>
               </a:rPr>
-              <a:t>Follow a natural-language instruction; see the scene through cameras</a:t>
-            </a:r>
-            <a:endParaRPr lang="en-US" sz="1600" dirty="0"/>
-          </a:p>
-          <a:p>
-            <a:pPr marL="342900" indent="-342900">
-              <a:spcAft>
-                <a:spcPts val="800"/>
-              </a:spcAft>
-              <a:buSzPct val="100000"/>
-              <a:buChar char="•"/>
-            </a:pPr>
-            <a:r>
-              <a:rPr lang="en-US" sz="1600" dirty="0">
-                <a:solidFill>
-                  <a:srgbClr val="1B2220"/>
-                </a:solidFill>
-                <a:latin typeface="Calibri" pitchFamily="34" charset="0"/>
-                <a:ea typeface="Calibri" pitchFamily="34" charset="-122"/>
-                <a:cs typeface="Calibri" pitchFamily="34" charset="-120"/>
-              </a:rPr>
               <a:t>Stay robust across 10 randomised scenes</a:t>
             </a:r>
             <a:endParaRPr lang="en-US" sz="1600" dirty="0"/>
@@ -2134,7 +2113,7 @@
       </p:sp>
       <p:pic>
         <p:nvPicPr>
-          <p:cNvPr id="4" name="Image 0" descr="G:\2026claude\bimanual-vla\out\cover_alt.png">    </p:cNvPr>
+          <p:cNvPr id="4" name="Image 0" descr="C:\Users\ASUS\bimanual-vla\out\cover_alt.png">    </p:cNvPr>
           <p:cNvPicPr>
             <a:picLocks noChangeAspect="1"/>
           </p:cNvPicPr>
@@ -2189,7 +2168,7 @@
                 <a:ea typeface="Calibri" pitchFamily="34" charset="-122"/>
                 <a:cs typeface="Calibri" pitchFamily="34" charset="-120"/>
               </a:rPr>
-              <a:t>MuJoCo · 2 × SO-101 · 12 position actuators · 3 cameras · 20 Hz control</a:t>
+              <a:t>MuJoCo · 2 × SO-101 · 12 position actuators · 5 cameras (2 on the wrists) · 20 Hz control</a:t>
             </a:r>
             <a:endParaRPr lang="en-US" sz="1200" dirty="0"/>
           </a:p>
@@ -2625,7 +2604,7 @@
                 <a:ea typeface="Calibri" pitchFamily="34" charset="-122"/>
                 <a:cs typeface="Calibri" pitchFamily="34" charset="-120"/>
               </a:rPr>
-              <a:t>Subtask token and grasp intent for each stage</a:t>
+              <a:t>Subtask token per stage; simulator state ends it (a learned head is experimental)</a:t>
             </a:r>
             <a:endParaRPr lang="en-US" sz="1400" dirty="0"/>
           </a:p>
@@ -2755,7 +2734,7 @@
                 <a:ea typeface="Calibri" pitchFamily="34" charset="-122"/>
                 <a:cs typeface="Calibri" pitchFamily="34" charset="-120"/>
               </a:rPr>
-              <a:t>2 cameras + 12 joints → 12 joint targets at 10 Hz, OpenVINO INT8</a:t>
+              <a:t>4 cameras (2 scene + 2 wrist) + 12 joints → 12 joint targets, OpenVINO INT8</a:t>
             </a:r>
             <a:endParaRPr lang="en-US" sz="1400" dirty="0"/>
           </a:p>
@@ -2885,7 +2864,7 @@
                 <a:ea typeface="Calibri" pitchFamily="34" charset="-122"/>
                 <a:cs typeface="Calibri" pitchFamily="34" charset="-120"/>
               </a:rPr>
-              <a:t>Dual SO-101 arms, drawer, plate, mug, bottle, utensils</a:t>
+              <a:t>Dual SO-101 arms, contact-only grasps, drawer, plate, mug, bead water, utensils</a:t>
             </a:r>
             <a:endParaRPr lang="en-US" sz="1400" dirty="0"/>
           </a:p>
@@ -3061,7 +3040,7 @@
                 <a:ea typeface="Courier New" pitchFamily="34" charset="-122"/>
                 <a:cs typeface="Courier New" pitchFamily="34" charset="-120"/>
               </a:rPr>
-              <a:t>"Hold the cup with the right arm and pour with the left."</a:t>
+              <a:t>"Pour a drink, then pass the spoon from the left arm to the right."</a:t>
             </a:r>
             <a:endParaRPr lang="en-US" sz="1400" dirty="0"/>
           </a:p>
@@ -3095,7 +3074,7 @@
                 <a:ea typeface="Courier New" pitchFamily="34" charset="-122"/>
                 <a:cs typeface="Courier New" pitchFamily="34" charset="-120"/>
               </a:rPr>
-              <a:t>pick_hold right mug ; pick_lift left bottle</a:t>
+              <a:t>open_drawer left ; pick_place right mug</a:t>
             </a:r>
             <a:endParaRPr lang="en-US" sz="1400" dirty="0"/>
           </a:p>
@@ -3112,7 +3091,7 @@
                 <a:ea typeface="Courier New" pitchFamily="34" charset="-122"/>
                 <a:cs typeface="Courier New" pitchFamily="34" charset="-120"/>
               </a:rPr>
-              <a:t>pour left mug</a:t>
+              <a:t>pick_lift right bottle</a:t>
             </a:r>
             <a:endParaRPr lang="en-US" sz="1400" dirty="0"/>
           </a:p>
@@ -3129,7 +3108,41 @@
                 <a:ea typeface="Courier New" pitchFamily="34" charset="-122"/>
                 <a:cs typeface="Courier New" pitchFamily="34" charset="-120"/>
               </a:rPr>
-              <a:t>return left bottle ; place right mug</a:t>
+              <a:t>pour right mug</a:t>
+            </a:r>
+            <a:endParaRPr lang="en-US" sz="1400" dirty="0"/>
+          </a:p>
+          <a:p>
+            <a:pPr indent="0" marL="0">
+              <a:buNone/>
+            </a:pPr>
+            <a:r>
+              <a:rPr lang="en-US" sz="1400" dirty="0">
+                <a:solidFill>
+                  <a:srgbClr val="E4E9E7"/>
+                </a:solidFill>
+                <a:latin typeface="Courier New" pitchFamily="34" charset="0"/>
+                <a:ea typeface="Courier New" pitchFamily="34" charset="-122"/>
+                <a:cs typeface="Courier New" pitchFamily="34" charset="-120"/>
+              </a:rPr>
+              <a:t>return right bottle</a:t>
+            </a:r>
+            <a:endParaRPr lang="en-US" sz="1400" dirty="0"/>
+          </a:p>
+          <a:p>
+            <a:pPr indent="0" marL="0">
+              <a:buNone/>
+            </a:pPr>
+            <a:r>
+              <a:rPr lang="en-US" sz="1400" dirty="0">
+                <a:solidFill>
+                  <a:srgbClr val="E4E9E7"/>
+                </a:solidFill>
+                <a:latin typeface="Courier New" pitchFamily="34" charset="0"/>
+                <a:ea typeface="Courier New" pitchFamily="34" charset="-122"/>
+                <a:cs typeface="Courier New" pitchFamily="34" charset="-120"/>
+              </a:rPr>
+              <a:t>handoff spoon left right</a:t>
             </a:r>
             <a:endParaRPr lang="en-US" sz="1400" dirty="0"/>
           </a:p>
@@ -3572,7 +3585,7 @@
                 <a:ea typeface="Cambria" pitchFamily="34" charset="-122"/>
                 <a:cs typeface="Cambria" pitchFamily="34" charset="-120"/>
               </a:rPr>
-              <a:t>Retry, repair, fall back</a:t>
+              <a:t>Complete, retry, fall back</a:t>
             </a:r>
             <a:endParaRPr lang="en-US" sz="1800" dirty="0"/>
           </a:p>
@@ -3611,7 +3624,7 @@
                 <a:ea typeface="Calibri" pitchFamily="34" charset="-122"/>
                 <a:cs typeface="Calibri" pitchFamily="34" charset="-120"/>
               </a:rPr>
-              <a:t>Errors go back to the model once; bad steps are dropped; a keyword planner is last resort.</a:t>
+              <a:t>Missing preconditions (bottle before a pour, drawer before a fork) are filled in and logged; errors go back to the model once; a keyword planner is last resort. 20 paraphrased instructions: 20/20 valid, 14/20 exactly right.</a:t>
             </a:r>
             <a:endParaRPr lang="en-US" sz="1400" dirty="0"/>
           </a:p>
@@ -3650,7 +3663,7 @@
                 <a:ea typeface="Calibri" pitchFamily="34" charset="-122"/>
                 <a:cs typeface="Calibri" pitchFamily="34" charset="-120"/>
               </a:rPr>
-              <a:t>2.12 s per plan on CPU · 2.22 s on Intel iGPU · 16 unit tests</a:t>
+              <a:t>1.44 s per plan on CPU · 2.34 s on Intel iGPU · 25 unit tests</a:t>
             </a:r>
             <a:endParaRPr lang="en-US" sz="1300" dirty="0"/>
           </a:p>
@@ -3760,7 +3773,7 @@
                 <a:ea typeface="Cambria" pitchFamily="34" charset="-122"/>
                 <a:cs typeface="Cambria" pitchFamily="34" charset="-120"/>
               </a:rPr>
-              <a:t>50</a:t>
+              <a:t>280</a:t>
             </a:r>
             <a:endParaRPr lang="en-US" sz="4800" dirty="0"/>
           </a:p>
@@ -3838,7 +3851,7 @@
                 <a:ea typeface="Cambria" pitchFamily="34" charset="-122"/>
                 <a:cs typeface="Cambria" pitchFamily="34" charset="-120"/>
               </a:rPr>
-              <a:t>32,285</a:t>
+              <a:t>405,058</a:t>
             </a:r>
             <a:endParaRPr lang="en-US" sz="4800" dirty="0"/>
           </a:p>
@@ -3916,7 +3929,7 @@
                 <a:ea typeface="Cambria" pitchFamily="34" charset="-122"/>
                 <a:cs typeface="Cambria" pitchFamily="34" charset="-120"/>
               </a:rPr>
-              <a:t>20k</a:t>
+              <a:t>120k</a:t>
             </a:r>
             <a:endParaRPr lang="en-US" sz="4800" dirty="0"/>
           </a:p>
@@ -4076,7 +4089,7 @@
                 <a:ea typeface="Calibri" pitchFamily="34" charset="-122"/>
                 <a:cs typeface="Calibri" pitchFamily="34" charset="-120"/>
               </a:rPr>
-              <a:t>Inputs: overhead + operator camera (128 × 128), 12 joint positions, one-hot subtask from the planner</a:t>
+              <a:t>Inputs: overhead, operator and both wrist cameras (128 × 128), 12 joint positions and velocities, one-hot subtask from the planner</a:t>
             </a:r>
             <a:endParaRPr lang="en-US" sz="1600" dirty="0"/>
           </a:p>
@@ -4097,7 +4110,7 @@
                 <a:ea typeface="Calibri" pitchFamily="34" charset="-122"/>
                 <a:cs typeface="Calibri" pitchFamily="34" charset="-120"/>
               </a:rPr>
-              <a:t>Output: the next 20 joint-target vectors; the arm executes 10 and re-plans every second</a:t>
+              <a:t>Output: the next 20 joint-target vectors at 10 Hz; inferred every step and the overlapping chunks blended (temporal ensembling)</a:t>
             </a:r>
             <a:endParaRPr lang="en-US" sz="1600" dirty="0"/>
           </a:p>
@@ -4118,7 +4131,7 @@
                 <a:ea typeface="Calibri" pitchFamily="34" charset="-122"/>
                 <a:cs typeface="Calibri" pitchFamily="34" charset="-120"/>
               </a:rPr>
-              <a:t>Demonstrations: scripted IK skills on randomised seeds (50 of 51 seeds kept); held-out seeds 0–9 never seen in training</a:t>
+              <a:t>Demonstrations: scripted contact skills on randomised seeds (29/30 on unseen seeds 1000-1029); held-out seeds 0–9 never seen in training</a:t>
             </a:r>
             <a:endParaRPr lang="en-US" sz="1600" dirty="0"/>
           </a:p>
@@ -4139,7 +4152,7 @@
                 <a:ea typeface="Calibri" pitchFamily="34" charset="-122"/>
                 <a:cs typeface="Calibri" pitchFamily="34" charset="-120"/>
               </a:rPr>
-              <a:t>Grasping is constraint-assisted: a closing gripper attaches the object it was sent for</a:t>
+              <a:t>No object is attached to a gripper: everything is held by finger contact and friction</a:t>
             </a:r>
             <a:endParaRPr lang="en-US" sz="1600" dirty="0"/>
           </a:p>
@@ -4210,7 +4223,7 @@
                 <a:ea typeface="Cambria" pitchFamily="34" charset="-122"/>
                 <a:cs typeface="Cambria" pitchFamily="34" charset="-120"/>
               </a:rPr>
-              <a:t>OpenVINO on Intel: INT8 policy in 5.9 ms</a:t>
+              <a:t>OpenVINO on Intel: INT8 policy in 4.9 ms</a:t>
             </a:r>
             <a:endParaRPr lang="en-US" sz="3400" dirty="0"/>
           </a:p>
@@ -4265,7 +4278,7 @@
                 <a:ea typeface="Cambria" pitchFamily="34" charset="-122"/>
                 <a:cs typeface="Cambria" pitchFamily="34" charset="-120"/>
               </a:rPr>
-              <a:t>2.7×</a:t>
+              <a:t>3.4×</a:t>
             </a:r>
             <a:endParaRPr lang="en-US" sz="6000" dirty="0"/>
           </a:p>
@@ -4347,7 +4360,7 @@
                 <a:ea typeface="Calibri" pitchFamily="34" charset="-122"/>
                 <a:cs typeface="Calibri" pitchFamily="34" charset="-120"/>
               </a:rPr>
-              <a:t>Action error after INT8: 0.02012 rad mean</a:t>
+              <a:t>Action error after INT8: 0.00501 rad mean</a:t>
             </a:r>
             <a:endParaRPr lang="en-US" sz="1400" dirty="0"/>
           </a:p>
@@ -4499,7 +4512,7 @@
                 <a:ea typeface="Cambria" pitchFamily="34" charset="-122"/>
                 <a:cs typeface="Cambria" pitchFamily="34" charset="-120"/>
               </a:rPr>
-              <a:t>Results on 10 held-out randomised seeds</a:t>
+              <a:t>Results on 10 randomised seeds</a:t>
             </a:r>
             <a:endParaRPr lang="en-US" sz="3400" dirty="0"/>
           </a:p>
@@ -4520,20 +4533,20 @@
           </p:nvPr>
         </p:nvGraphicFramePr>
         <p:xfrm>
-          <a:off x="548640" y="1463040"/>
-          <a:ext cx="6949440" cy="914400"/>
+          <a:off x="548640" y="1371600"/>
+          <a:ext cx="7223760" cy="914400"/>
         </p:xfrm>
         <a:graphic>
           <a:graphicData uri="http://schemas.openxmlformats.org/drawingml/2006/table">
             <a:tbl>
               <a:tblPr/>
               <a:tblGrid>
-                <a:gridCol w="2834640"/>
+                <a:gridCol w="2651760"/>
+                <a:gridCol w="1188720"/>
                 <a:gridCol w="1371600"/>
-                <a:gridCol w="1371600"/>
-                <a:gridCol w="1371600"/>
+                <a:gridCol w="2011680"/>
               </a:tblGrid>
-              <a:tr h="457200">
+              <a:tr h="402336">
                 <a:tc>
                   <a:txBody>
                     <a:bodyPr/>
@@ -4755,7 +4768,7 @@
                           <a:ea typeface="Calibri" pitchFamily="34" charset="-122"/>
                           <a:cs typeface="Calibri" pitchFamily="34" charset="-120"/>
                         </a:rPr>
-                        <a:t>Hybrid</a:t>
+                        <a:t>Hybrid (policy + script)</a:t>
                       </a:r>
                       <a:endParaRPr lang="en-US" sz="1400" dirty="0">
                         <a:latin typeface="Calibri" charset="0"/>
@@ -4807,7 +4820,7 @@
                   </a:tcPr>
                 </a:tc>
               </a:tr>
-              <a:tr h="457200">
+              <a:tr h="402336">
                 <a:tc>
                   <a:txBody>
                     <a:bodyPr/>
@@ -5029,7 +5042,7 @@
                           <a:ea typeface="Calibri" pitchFamily="34" charset="-122"/>
                           <a:cs typeface="Calibri" pitchFamily="34" charset="-120"/>
                         </a:rPr>
-                        <a:t>10/10</a:t>
+                        <a:t>10 (0 assisted)</a:t>
                       </a:r>
                       <a:endParaRPr lang="en-US" sz="1400" dirty="0">
                         <a:latin typeface="Calibri" charset="0"/>
@@ -5081,7 +5094,7 @@
                   </a:tcPr>
                 </a:tc>
               </a:tr>
-              <a:tr h="457200">
+              <a:tr h="402336">
                 <a:tc>
                   <a:txBody>
                     <a:bodyPr/>
@@ -5099,7 +5112,7 @@
                           <a:ea typeface="Calibri" pitchFamily="34" charset="-122"/>
                           <a:cs typeface="Calibri" pitchFamily="34" charset="-120"/>
                         </a:rPr>
-                        <a:t>Spoon placed</a:t>
+                        <a:t>Mug placed</a:t>
                       </a:r>
                       <a:endParaRPr lang="en-US" sz="1400" dirty="0">
                         <a:latin typeface="Calibri" charset="0"/>
@@ -5235,7 +5248,487 @@
                           <a:ea typeface="Calibri" pitchFamily="34" charset="-122"/>
                           <a:cs typeface="Calibri" pitchFamily="34" charset="-120"/>
                         </a:rPr>
-                        <a:t>4/10</a:t>
+                        <a:t>10/10</a:t>
+                      </a:r>
+                      <a:endParaRPr lang="en-US" sz="1400" dirty="0">
+                        <a:latin typeface="Calibri" charset="0"/>
+                        <a:ea typeface="Calibri" charset="0"/>
+                        <a:cs typeface="Calibri" charset="0"/>
+                      </a:endParaRPr>
+                    </a:p>
+                  </a:txBody>
+                  <a:tcPr marL="91440" marR="91440" marT="45720" marB="45720">
+                    <a:lnL w="9525" cap="flat" cmpd="sng" algn="ctr">
+                      <a:solidFill>
+                        <a:srgbClr val="D5DCD9"/>
+                      </a:solidFill>
+                      <a:prstDash val="solid"/>
+                      <a:round/>
+                      <a:headEnd type="none" w="med" len="med"/>
+                      <a:tailEnd type="none" w="med" len="med"/>
+                    </a:lnL>
+                    <a:lnR w="9525" cap="flat" cmpd="sng" algn="ctr">
+                      <a:solidFill>
+                        <a:srgbClr val="D5DCD9"/>
+                      </a:solidFill>
+                      <a:prstDash val="solid"/>
+                      <a:round/>
+                      <a:headEnd type="none" w="med" len="med"/>
+                      <a:tailEnd type="none" w="med" len="med"/>
+                    </a:lnR>
+                    <a:lnT w="9525" cap="flat" cmpd="sng" algn="ctr">
+                      <a:solidFill>
+                        <a:srgbClr val="D5DCD9"/>
+                      </a:solidFill>
+                      <a:prstDash val="solid"/>
+                      <a:round/>
+                      <a:headEnd type="none" w="med" len="med"/>
+                      <a:tailEnd type="none" w="med" len="med"/>
+                    </a:lnT>
+                    <a:lnB w="9525" cap="flat" cmpd="sng" algn="ctr">
+                      <a:solidFill>
+                        <a:srgbClr val="D5DCD9"/>
+                      </a:solidFill>
+                      <a:prstDash val="solid"/>
+                      <a:round/>
+                      <a:headEnd type="none" w="med" len="med"/>
+                      <a:tailEnd type="none" w="med" len="med"/>
+                    </a:lnB>
+                    <a:solidFill>
+                      <a:srgbClr val="FFFFFF"/>
+                    </a:solidFill>
+                  </a:tcPr>
+                </a:tc>
+                <a:tc>
+                  <a:txBody>
+                    <a:bodyPr/>
+                    <a:lstStyle/>
+                    <a:p>
+                      <a:pPr algn="ctr" indent="0" marL="0">
+                        <a:buNone/>
+                      </a:pPr>
+                      <a:r>
+                        <a:rPr lang="en-US" sz="1400" dirty="0">
+                          <a:solidFill>
+                            <a:srgbClr val="1B2220"/>
+                          </a:solidFill>
+                          <a:latin typeface="Calibri" pitchFamily="34" charset="0"/>
+                          <a:ea typeface="Calibri" pitchFamily="34" charset="-122"/>
+                          <a:cs typeface="Calibri" pitchFamily="34" charset="-120"/>
+                        </a:rPr>
+                        <a:t>7 (0 assisted)</a:t>
+                      </a:r>
+                      <a:endParaRPr lang="en-US" sz="1400" dirty="0">
+                        <a:latin typeface="Calibri" charset="0"/>
+                        <a:ea typeface="Calibri" charset="0"/>
+                        <a:cs typeface="Calibri" charset="0"/>
+                      </a:endParaRPr>
+                    </a:p>
+                  </a:txBody>
+                  <a:tcPr marL="91440" marR="91440" marT="45720" marB="45720">
+                    <a:lnL w="9525" cap="flat" cmpd="sng" algn="ctr">
+                      <a:solidFill>
+                        <a:srgbClr val="D5DCD9"/>
+                      </a:solidFill>
+                      <a:prstDash val="solid"/>
+                      <a:round/>
+                      <a:headEnd type="none" w="med" len="med"/>
+                      <a:tailEnd type="none" w="med" len="med"/>
+                    </a:lnL>
+                    <a:lnR w="9525" cap="flat" cmpd="sng" algn="ctr">
+                      <a:solidFill>
+                        <a:srgbClr val="D5DCD9"/>
+                      </a:solidFill>
+                      <a:prstDash val="solid"/>
+                      <a:round/>
+                      <a:headEnd type="none" w="med" len="med"/>
+                      <a:tailEnd type="none" w="med" len="med"/>
+                    </a:lnR>
+                    <a:lnT w="9525" cap="flat" cmpd="sng" algn="ctr">
+                      <a:solidFill>
+                        <a:srgbClr val="D5DCD9"/>
+                      </a:solidFill>
+                      <a:prstDash val="solid"/>
+                      <a:round/>
+                      <a:headEnd type="none" w="med" len="med"/>
+                      <a:tailEnd type="none" w="med" len="med"/>
+                    </a:lnT>
+                    <a:lnB w="9525" cap="flat" cmpd="sng" algn="ctr">
+                      <a:solidFill>
+                        <a:srgbClr val="D5DCD9"/>
+                      </a:solidFill>
+                      <a:prstDash val="solid"/>
+                      <a:round/>
+                      <a:headEnd type="none" w="med" len="med"/>
+                      <a:tailEnd type="none" w="med" len="med"/>
+                    </a:lnB>
+                    <a:solidFill>
+                      <a:srgbClr val="FFFFFF"/>
+                    </a:solidFill>
+                  </a:tcPr>
+                </a:tc>
+              </a:tr>
+              <a:tr h="402336">
+                <a:tc>
+                  <a:txBody>
+                    <a:bodyPr/>
+                    <a:lstStyle/>
+                    <a:p>
+                      <a:pPr indent="0" marL="0">
+                        <a:buNone/>
+                      </a:pPr>
+                      <a:r>
+                        <a:rPr lang="en-US" sz="1400" dirty="0">
+                          <a:solidFill>
+                            <a:srgbClr val="1B2220"/>
+                          </a:solidFill>
+                          <a:latin typeface="Calibri" pitchFamily="34" charset="0"/>
+                          <a:ea typeface="Calibri" pitchFamily="34" charset="-122"/>
+                          <a:cs typeface="Calibri" pitchFamily="34" charset="-120"/>
+                        </a:rPr>
+                        <a:t>Plate on placemat</a:t>
+                      </a:r>
+                      <a:endParaRPr lang="en-US" sz="1400" dirty="0">
+                        <a:latin typeface="Calibri" charset="0"/>
+                        <a:ea typeface="Calibri" charset="0"/>
+                        <a:cs typeface="Calibri" charset="0"/>
+                      </a:endParaRPr>
+                    </a:p>
+                  </a:txBody>
+                  <a:tcPr marL="91440" marR="91440" marT="45720" marB="45720">
+                    <a:lnL w="9525" cap="flat" cmpd="sng" algn="ctr">
+                      <a:solidFill>
+                        <a:srgbClr val="D5DCD9"/>
+                      </a:solidFill>
+                      <a:prstDash val="solid"/>
+                      <a:round/>
+                      <a:headEnd type="none" w="med" len="med"/>
+                      <a:tailEnd type="none" w="med" len="med"/>
+                    </a:lnL>
+                    <a:lnR w="9525" cap="flat" cmpd="sng" algn="ctr">
+                      <a:solidFill>
+                        <a:srgbClr val="D5DCD9"/>
+                      </a:solidFill>
+                      <a:prstDash val="solid"/>
+                      <a:round/>
+                      <a:headEnd type="none" w="med" len="med"/>
+                      <a:tailEnd type="none" w="med" len="med"/>
+                    </a:lnR>
+                    <a:lnT w="9525" cap="flat" cmpd="sng" algn="ctr">
+                      <a:solidFill>
+                        <a:srgbClr val="D5DCD9"/>
+                      </a:solidFill>
+                      <a:prstDash val="solid"/>
+                      <a:round/>
+                      <a:headEnd type="none" w="med" len="med"/>
+                      <a:tailEnd type="none" w="med" len="med"/>
+                    </a:lnT>
+                    <a:lnB w="9525" cap="flat" cmpd="sng" algn="ctr">
+                      <a:solidFill>
+                        <a:srgbClr val="D5DCD9"/>
+                      </a:solidFill>
+                      <a:prstDash val="solid"/>
+                      <a:round/>
+                      <a:headEnd type="none" w="med" len="med"/>
+                      <a:tailEnd type="none" w="med" len="med"/>
+                    </a:lnB>
+                    <a:solidFill>
+                      <a:srgbClr val="FFFFFF"/>
+                    </a:solidFill>
+                  </a:tcPr>
+                </a:tc>
+                <a:tc>
+                  <a:txBody>
+                    <a:bodyPr/>
+                    <a:lstStyle/>
+                    <a:p>
+                      <a:pPr algn="ctr" indent="0" marL="0">
+                        <a:buNone/>
+                      </a:pPr>
+                      <a:r>
+                        <a:rPr lang="en-US" sz="1400" b="1" dirty="0">
+                          <a:solidFill>
+                            <a:srgbClr val="2F7A4F"/>
+                          </a:solidFill>
+                          <a:latin typeface="Calibri" pitchFamily="34" charset="0"/>
+                          <a:ea typeface="Calibri" pitchFamily="34" charset="-122"/>
+                          <a:cs typeface="Calibri" pitchFamily="34" charset="-120"/>
+                        </a:rPr>
+                        <a:t>10/10</a:t>
+                      </a:r>
+                      <a:endParaRPr lang="en-US" sz="1400" dirty="0">
+                        <a:latin typeface="Calibri" charset="0"/>
+                        <a:ea typeface="Calibri" charset="0"/>
+                        <a:cs typeface="Calibri" charset="0"/>
+                      </a:endParaRPr>
+                    </a:p>
+                  </a:txBody>
+                  <a:tcPr marL="91440" marR="91440" marT="45720" marB="45720">
+                    <a:lnL w="9525" cap="flat" cmpd="sng" algn="ctr">
+                      <a:solidFill>
+                        <a:srgbClr val="D5DCD9"/>
+                      </a:solidFill>
+                      <a:prstDash val="solid"/>
+                      <a:round/>
+                      <a:headEnd type="none" w="med" len="med"/>
+                      <a:tailEnd type="none" w="med" len="med"/>
+                    </a:lnL>
+                    <a:lnR w="9525" cap="flat" cmpd="sng" algn="ctr">
+                      <a:solidFill>
+                        <a:srgbClr val="D5DCD9"/>
+                      </a:solidFill>
+                      <a:prstDash val="solid"/>
+                      <a:round/>
+                      <a:headEnd type="none" w="med" len="med"/>
+                      <a:tailEnd type="none" w="med" len="med"/>
+                    </a:lnR>
+                    <a:lnT w="9525" cap="flat" cmpd="sng" algn="ctr">
+                      <a:solidFill>
+                        <a:srgbClr val="D5DCD9"/>
+                      </a:solidFill>
+                      <a:prstDash val="solid"/>
+                      <a:round/>
+                      <a:headEnd type="none" w="med" len="med"/>
+                      <a:tailEnd type="none" w="med" len="med"/>
+                    </a:lnT>
+                    <a:lnB w="9525" cap="flat" cmpd="sng" algn="ctr">
+                      <a:solidFill>
+                        <a:srgbClr val="D5DCD9"/>
+                      </a:solidFill>
+                      <a:prstDash val="solid"/>
+                      <a:round/>
+                      <a:headEnd type="none" w="med" len="med"/>
+                      <a:tailEnd type="none" w="med" len="med"/>
+                    </a:lnB>
+                    <a:solidFill>
+                      <a:srgbClr val="FFFFFF"/>
+                    </a:solidFill>
+                  </a:tcPr>
+                </a:tc>
+                <a:tc>
+                  <a:txBody>
+                    <a:bodyPr/>
+                    <a:lstStyle/>
+                    <a:p>
+                      <a:pPr algn="ctr" indent="0" marL="0">
+                        <a:buNone/>
+                      </a:pPr>
+                      <a:r>
+                        <a:rPr lang="en-US" sz="1400" dirty="0">
+                          <a:solidFill>
+                            <a:srgbClr val="1B2220"/>
+                          </a:solidFill>
+                          <a:latin typeface="Calibri" pitchFamily="34" charset="0"/>
+                          <a:ea typeface="Calibri" pitchFamily="34" charset="-122"/>
+                          <a:cs typeface="Calibri" pitchFamily="34" charset="-120"/>
+                        </a:rPr>
+                        <a:t>10/10</a:t>
+                      </a:r>
+                      <a:endParaRPr lang="en-US" sz="1400" dirty="0">
+                        <a:latin typeface="Calibri" charset="0"/>
+                        <a:ea typeface="Calibri" charset="0"/>
+                        <a:cs typeface="Calibri" charset="0"/>
+                      </a:endParaRPr>
+                    </a:p>
+                  </a:txBody>
+                  <a:tcPr marL="91440" marR="91440" marT="45720" marB="45720">
+                    <a:lnL w="9525" cap="flat" cmpd="sng" algn="ctr">
+                      <a:solidFill>
+                        <a:srgbClr val="D5DCD9"/>
+                      </a:solidFill>
+                      <a:prstDash val="solid"/>
+                      <a:round/>
+                      <a:headEnd type="none" w="med" len="med"/>
+                      <a:tailEnd type="none" w="med" len="med"/>
+                    </a:lnL>
+                    <a:lnR w="9525" cap="flat" cmpd="sng" algn="ctr">
+                      <a:solidFill>
+                        <a:srgbClr val="D5DCD9"/>
+                      </a:solidFill>
+                      <a:prstDash val="solid"/>
+                      <a:round/>
+                      <a:headEnd type="none" w="med" len="med"/>
+                      <a:tailEnd type="none" w="med" len="med"/>
+                    </a:lnR>
+                    <a:lnT w="9525" cap="flat" cmpd="sng" algn="ctr">
+                      <a:solidFill>
+                        <a:srgbClr val="D5DCD9"/>
+                      </a:solidFill>
+                      <a:prstDash val="solid"/>
+                      <a:round/>
+                      <a:headEnd type="none" w="med" len="med"/>
+                      <a:tailEnd type="none" w="med" len="med"/>
+                    </a:lnT>
+                    <a:lnB w="9525" cap="flat" cmpd="sng" algn="ctr">
+                      <a:solidFill>
+                        <a:srgbClr val="D5DCD9"/>
+                      </a:solidFill>
+                      <a:prstDash val="solid"/>
+                      <a:round/>
+                      <a:headEnd type="none" w="med" len="med"/>
+                      <a:tailEnd type="none" w="med" len="med"/>
+                    </a:lnB>
+                    <a:solidFill>
+                      <a:srgbClr val="FFFFFF"/>
+                    </a:solidFill>
+                  </a:tcPr>
+                </a:tc>
+                <a:tc>
+                  <a:txBody>
+                    <a:bodyPr/>
+                    <a:lstStyle/>
+                    <a:p>
+                      <a:pPr algn="ctr" indent="0" marL="0">
+                        <a:buNone/>
+                      </a:pPr>
+                      <a:r>
+                        <a:rPr lang="en-US" sz="1400" dirty="0">
+                          <a:solidFill>
+                            <a:srgbClr val="1B2220"/>
+                          </a:solidFill>
+                          <a:latin typeface="Calibri" pitchFamily="34" charset="0"/>
+                          <a:ea typeface="Calibri" pitchFamily="34" charset="-122"/>
+                          <a:cs typeface="Calibri" pitchFamily="34" charset="-120"/>
+                        </a:rPr>
+                        <a:t>7 (0 assisted)</a:t>
+                      </a:r>
+                      <a:endParaRPr lang="en-US" sz="1400" dirty="0">
+                        <a:latin typeface="Calibri" charset="0"/>
+                        <a:ea typeface="Calibri" charset="0"/>
+                        <a:cs typeface="Calibri" charset="0"/>
+                      </a:endParaRPr>
+                    </a:p>
+                  </a:txBody>
+                  <a:tcPr marL="91440" marR="91440" marT="45720" marB="45720">
+                    <a:lnL w="9525" cap="flat" cmpd="sng" algn="ctr">
+                      <a:solidFill>
+                        <a:srgbClr val="D5DCD9"/>
+                      </a:solidFill>
+                      <a:prstDash val="solid"/>
+                      <a:round/>
+                      <a:headEnd type="none" w="med" len="med"/>
+                      <a:tailEnd type="none" w="med" len="med"/>
+                    </a:lnL>
+                    <a:lnR w="9525" cap="flat" cmpd="sng" algn="ctr">
+                      <a:solidFill>
+                        <a:srgbClr val="D5DCD9"/>
+                      </a:solidFill>
+                      <a:prstDash val="solid"/>
+                      <a:round/>
+                      <a:headEnd type="none" w="med" len="med"/>
+                      <a:tailEnd type="none" w="med" len="med"/>
+                    </a:lnR>
+                    <a:lnT w="9525" cap="flat" cmpd="sng" algn="ctr">
+                      <a:solidFill>
+                        <a:srgbClr val="D5DCD9"/>
+                      </a:solidFill>
+                      <a:prstDash val="solid"/>
+                      <a:round/>
+                      <a:headEnd type="none" w="med" len="med"/>
+                      <a:tailEnd type="none" w="med" len="med"/>
+                    </a:lnT>
+                    <a:lnB w="9525" cap="flat" cmpd="sng" algn="ctr">
+                      <a:solidFill>
+                        <a:srgbClr val="D5DCD9"/>
+                      </a:solidFill>
+                      <a:prstDash val="solid"/>
+                      <a:round/>
+                      <a:headEnd type="none" w="med" len="med"/>
+                      <a:tailEnd type="none" w="med" len="med"/>
+                    </a:lnB>
+                    <a:solidFill>
+                      <a:srgbClr val="FFFFFF"/>
+                    </a:solidFill>
+                  </a:tcPr>
+                </a:tc>
+              </a:tr>
+              <a:tr h="402336">
+                <a:tc>
+                  <a:txBody>
+                    <a:bodyPr/>
+                    <a:lstStyle/>
+                    <a:p>
+                      <a:pPr indent="0" marL="0">
+                        <a:buNone/>
+                      </a:pPr>
+                      <a:r>
+                        <a:rPr lang="en-US" sz="1400" dirty="0">
+                          <a:solidFill>
+                            <a:srgbClr val="1B2220"/>
+                          </a:solidFill>
+                          <a:latin typeface="Calibri" pitchFamily="34" charset="0"/>
+                          <a:ea typeface="Calibri" pitchFamily="34" charset="-122"/>
+                          <a:cs typeface="Calibri" pitchFamily="34" charset="-120"/>
+                        </a:rPr>
+                        <a:t>Fork placed</a:t>
+                      </a:r>
+                      <a:endParaRPr lang="en-US" sz="1400" dirty="0">
+                        <a:latin typeface="Calibri" charset="0"/>
+                        <a:ea typeface="Calibri" charset="0"/>
+                        <a:cs typeface="Calibri" charset="0"/>
+                      </a:endParaRPr>
+                    </a:p>
+                  </a:txBody>
+                  <a:tcPr marL="91440" marR="91440" marT="45720" marB="45720">
+                    <a:lnL w="9525" cap="flat" cmpd="sng" algn="ctr">
+                      <a:solidFill>
+                        <a:srgbClr val="D5DCD9"/>
+                      </a:solidFill>
+                      <a:prstDash val="solid"/>
+                      <a:round/>
+                      <a:headEnd type="none" w="med" len="med"/>
+                      <a:tailEnd type="none" w="med" len="med"/>
+                    </a:lnL>
+                    <a:lnR w="9525" cap="flat" cmpd="sng" algn="ctr">
+                      <a:solidFill>
+                        <a:srgbClr val="D5DCD9"/>
+                      </a:solidFill>
+                      <a:prstDash val="solid"/>
+                      <a:round/>
+                      <a:headEnd type="none" w="med" len="med"/>
+                      <a:tailEnd type="none" w="med" len="med"/>
+                    </a:lnR>
+                    <a:lnT w="9525" cap="flat" cmpd="sng" algn="ctr">
+                      <a:solidFill>
+                        <a:srgbClr val="D5DCD9"/>
+                      </a:solidFill>
+                      <a:prstDash val="solid"/>
+                      <a:round/>
+                      <a:headEnd type="none" w="med" len="med"/>
+                      <a:tailEnd type="none" w="med" len="med"/>
+                    </a:lnT>
+                    <a:lnB w="9525" cap="flat" cmpd="sng" algn="ctr">
+                      <a:solidFill>
+                        <a:srgbClr val="D5DCD9"/>
+                      </a:solidFill>
+                      <a:prstDash val="solid"/>
+                      <a:round/>
+                      <a:headEnd type="none" w="med" len="med"/>
+                      <a:tailEnd type="none" w="med" len="med"/>
+                    </a:lnB>
+                    <a:solidFill>
+                      <a:srgbClr val="FFFFFF"/>
+                    </a:solidFill>
+                  </a:tcPr>
+                </a:tc>
+                <a:tc>
+                  <a:txBody>
+                    <a:bodyPr/>
+                    <a:lstStyle/>
+                    <a:p>
+                      <a:pPr algn="ctr" indent="0" marL="0">
+                        <a:buNone/>
+                      </a:pPr>
+                      <a:r>
+                        <a:rPr lang="en-US" sz="1400" b="1" dirty="0">
+                          <a:solidFill>
+                            <a:srgbClr val="2F7A4F"/>
+                          </a:solidFill>
+                          <a:latin typeface="Calibri" pitchFamily="34" charset="0"/>
+                          <a:ea typeface="Calibri" pitchFamily="34" charset="-122"/>
+                          <a:cs typeface="Calibri" pitchFamily="34" charset="-120"/>
+                        </a:rPr>
+                        <a:t>10/10</a:t>
                       </a:r>
                       <a:endParaRPr lang="en-US" sz="1400" dirty="0">
                         <a:latin typeface="Calibri" charset="0"/>
@@ -5354,8 +5847,76 @@
                     </a:solidFill>
                   </a:tcPr>
                 </a:tc>
+                <a:tc>
+                  <a:txBody>
+                    <a:bodyPr/>
+                    <a:lstStyle/>
+                    <a:p>
+                      <a:pPr algn="ctr" indent="0" marL="0">
+                        <a:buNone/>
+                      </a:pPr>
+                      <a:r>
+                        <a:rPr lang="en-US" sz="1400" dirty="0">
+                          <a:solidFill>
+                            <a:srgbClr val="1B2220"/>
+                          </a:solidFill>
+                          <a:latin typeface="Calibri" pitchFamily="34" charset="0"/>
+                          <a:ea typeface="Calibri" pitchFamily="34" charset="-122"/>
+                          <a:cs typeface="Calibri" pitchFamily="34" charset="-120"/>
+                        </a:rPr>
+                        <a:t>9 (2 assisted)</a:t>
+                      </a:r>
+                      <a:endParaRPr lang="en-US" sz="1400" dirty="0">
+                        <a:latin typeface="Calibri" charset="0"/>
+                        <a:ea typeface="Calibri" charset="0"/>
+                        <a:cs typeface="Calibri" charset="0"/>
+                      </a:endParaRPr>
+                    </a:p>
+                  </a:txBody>
+                  <a:tcPr marL="91440" marR="91440" marT="45720" marB="45720">
+                    <a:lnL w="9525" cap="flat" cmpd="sng" algn="ctr">
+                      <a:solidFill>
+                        <a:srgbClr val="D5DCD9"/>
+                      </a:solidFill>
+                      <a:prstDash val="solid"/>
+                      <a:round/>
+                      <a:headEnd type="none" w="med" len="med"/>
+                      <a:tailEnd type="none" w="med" len="med"/>
+                    </a:lnL>
+                    <a:lnR w="9525" cap="flat" cmpd="sng" algn="ctr">
+                      <a:solidFill>
+                        <a:srgbClr val="D5DCD9"/>
+                      </a:solidFill>
+                      <a:prstDash val="solid"/>
+                      <a:round/>
+                      <a:headEnd type="none" w="med" len="med"/>
+                      <a:tailEnd type="none" w="med" len="med"/>
+                    </a:lnR>
+                    <a:lnT w="9525" cap="flat" cmpd="sng" algn="ctr">
+                      <a:solidFill>
+                        <a:srgbClr val="D5DCD9"/>
+                      </a:solidFill>
+                      <a:prstDash val="solid"/>
+                      <a:round/>
+                      <a:headEnd type="none" w="med" len="med"/>
+                      <a:tailEnd type="none" w="med" len="med"/>
+                    </a:lnT>
+                    <a:lnB w="9525" cap="flat" cmpd="sng" algn="ctr">
+                      <a:solidFill>
+                        <a:srgbClr val="D5DCD9"/>
+                      </a:solidFill>
+                      <a:prstDash val="solid"/>
+                      <a:round/>
+                      <a:headEnd type="none" w="med" len="med"/>
+                      <a:tailEnd type="none" w="med" len="med"/>
+                    </a:lnB>
+                    <a:solidFill>
+                      <a:srgbClr val="FFFFFF"/>
+                    </a:solidFill>
+                  </a:tcPr>
+                </a:tc>
               </a:tr>
-              <a:tr h="457200">
+              <a:tr h="402336">
                 <a:tc>
                   <a:txBody>
                     <a:bodyPr/>
@@ -5373,7 +5934,7 @@
                           <a:ea typeface="Calibri" pitchFamily="34" charset="-122"/>
                           <a:cs typeface="Calibri" pitchFamily="34" charset="-120"/>
                         </a:rPr>
-                        <a:t>Fork handed off + placed</a:t>
+                        <a:t>Spoon handed over + placed</a:t>
                       </a:r>
                       <a:endParaRPr lang="en-US" sz="1400" dirty="0">
                         <a:latin typeface="Calibri" charset="0"/>
@@ -5509,7 +6070,7 @@
                           <a:ea typeface="Calibri" pitchFamily="34" charset="-122"/>
                           <a:cs typeface="Calibri" pitchFamily="34" charset="-120"/>
                         </a:rPr>
-                        <a:t>5/10</a:t>
+                        <a:t>3/10</a:t>
                       </a:r>
                       <a:endParaRPr lang="en-US" sz="1400" dirty="0">
                         <a:latin typeface="Calibri" charset="0"/>
@@ -5577,7 +6138,7 @@
                           <a:ea typeface="Calibri" pitchFamily="34" charset="-122"/>
                           <a:cs typeface="Calibri" pitchFamily="34" charset="-120"/>
                         </a:rPr>
-                        <a:t>9/10</a:t>
+                        <a:t>6 (8 assisted)</a:t>
                       </a:r>
                       <a:endParaRPr lang="en-US" sz="1400" dirty="0">
                         <a:latin typeface="Calibri" charset="0"/>
@@ -5629,7 +6190,7 @@
                   </a:tcPr>
                 </a:tc>
               </a:tr>
-              <a:tr h="457200">
+              <a:tr h="402336">
                 <a:tc>
                   <a:txBody>
                     <a:bodyPr/>
@@ -5647,7 +6208,7 @@
                           <a:ea typeface="Calibri" pitchFamily="34" charset="-122"/>
                           <a:cs typeface="Calibri" pitchFamily="34" charset="-120"/>
                         </a:rPr>
-                        <a:t>Plate on placemat</a:t>
+                        <a:t>Poured (≥ 60 % of the water)</a:t>
                       </a:r>
                       <a:endParaRPr lang="en-US" sz="1400" dirty="0">
                         <a:latin typeface="Calibri" charset="0"/>
@@ -5783,7 +6344,7 @@
                           <a:ea typeface="Calibri" pitchFamily="34" charset="-122"/>
                           <a:cs typeface="Calibri" pitchFamily="34" charset="-120"/>
                         </a:rPr>
-                        <a:t>10/10</a:t>
+                        <a:t>0/10</a:t>
                       </a:r>
                       <a:endParaRPr lang="en-US" sz="1400" dirty="0">
                         <a:latin typeface="Calibri" charset="0"/>
@@ -5851,7 +6412,7 @@
                           <a:ea typeface="Calibri" pitchFamily="34" charset="-122"/>
                           <a:cs typeface="Calibri" pitchFamily="34" charset="-120"/>
                         </a:rPr>
-                        <a:t>10/10</a:t>
+                        <a:t>3 (10 assisted)</a:t>
                       </a:r>
                       <a:endParaRPr lang="en-US" sz="1400" dirty="0">
                         <a:latin typeface="Calibri" charset="0"/>
@@ -5903,7 +6464,7 @@
                   </a:tcPr>
                 </a:tc>
               </a:tr>
-              <a:tr h="457200">
+              <a:tr h="402336">
                 <a:tc>
                   <a:txBody>
                     <a:bodyPr/>
@@ -5921,7 +6482,7 @@
                           <a:ea typeface="Calibri" pitchFamily="34" charset="-122"/>
                           <a:cs typeface="Calibri" pitchFamily="34" charset="-120"/>
                         </a:rPr>
-                        <a:t>Mug placed</a:t>
+                        <a:t>Bottle put back</a:t>
                       </a:r>
                       <a:endParaRPr lang="en-US" sz="1400" dirty="0">
                         <a:latin typeface="Calibri" charset="0"/>
@@ -6057,7 +6618,7 @@
                           <a:ea typeface="Calibri" pitchFamily="34" charset="-122"/>
                           <a:cs typeface="Calibri" pitchFamily="34" charset="-120"/>
                         </a:rPr>
-                        <a:t>10/10</a:t>
+                        <a:t>2/10</a:t>
                       </a:r>
                       <a:endParaRPr lang="en-US" sz="1400" dirty="0">
                         <a:latin typeface="Calibri" charset="0"/>
@@ -6125,7 +6686,7 @@
                           <a:ea typeface="Calibri" pitchFamily="34" charset="-122"/>
                           <a:cs typeface="Calibri" pitchFamily="34" charset="-120"/>
                         </a:rPr>
-                        <a:t>9/10</a:t>
+                        <a:t>1 (3 assisted)</a:t>
                       </a:r>
                       <a:endParaRPr lang="en-US" sz="1400" dirty="0">
                         <a:latin typeface="Calibri" charset="0"/>
@@ -6177,281 +6738,7 @@
                   </a:tcPr>
                 </a:tc>
               </a:tr>
-              <a:tr h="457200">
-                <a:tc>
-                  <a:txBody>
-                    <a:bodyPr/>
-                    <a:lstStyle/>
-                    <a:p>
-                      <a:pPr indent="0" marL="0">
-                        <a:buNone/>
-                      </a:pPr>
-                      <a:r>
-                        <a:rPr lang="en-US" sz="1400" dirty="0">
-                          <a:solidFill>
-                            <a:srgbClr val="1B2220"/>
-                          </a:solidFill>
-                          <a:latin typeface="Calibri" pitchFamily="34" charset="0"/>
-                          <a:ea typeface="Calibri" pitchFamily="34" charset="-122"/>
-                          <a:cs typeface="Calibri" pitchFamily="34" charset="-120"/>
-                        </a:rPr>
-                        <a:t>Poured</a:t>
-                      </a:r>
-                      <a:endParaRPr lang="en-US" sz="1400" dirty="0">
-                        <a:latin typeface="Calibri" charset="0"/>
-                        <a:ea typeface="Calibri" charset="0"/>
-                        <a:cs typeface="Calibri" charset="0"/>
-                      </a:endParaRPr>
-                    </a:p>
-                  </a:txBody>
-                  <a:tcPr marL="91440" marR="91440" marT="45720" marB="45720">
-                    <a:lnL w="9525" cap="flat" cmpd="sng" algn="ctr">
-                      <a:solidFill>
-                        <a:srgbClr val="D5DCD9"/>
-                      </a:solidFill>
-                      <a:prstDash val="solid"/>
-                      <a:round/>
-                      <a:headEnd type="none" w="med" len="med"/>
-                      <a:tailEnd type="none" w="med" len="med"/>
-                    </a:lnL>
-                    <a:lnR w="9525" cap="flat" cmpd="sng" algn="ctr">
-                      <a:solidFill>
-                        <a:srgbClr val="D5DCD9"/>
-                      </a:solidFill>
-                      <a:prstDash val="solid"/>
-                      <a:round/>
-                      <a:headEnd type="none" w="med" len="med"/>
-                      <a:tailEnd type="none" w="med" len="med"/>
-                    </a:lnR>
-                    <a:lnT w="9525" cap="flat" cmpd="sng" algn="ctr">
-                      <a:solidFill>
-                        <a:srgbClr val="D5DCD9"/>
-                      </a:solidFill>
-                      <a:prstDash val="solid"/>
-                      <a:round/>
-                      <a:headEnd type="none" w="med" len="med"/>
-                      <a:tailEnd type="none" w="med" len="med"/>
-                    </a:lnT>
-                    <a:lnB w="9525" cap="flat" cmpd="sng" algn="ctr">
-                      <a:solidFill>
-                        <a:srgbClr val="D5DCD9"/>
-                      </a:solidFill>
-                      <a:prstDash val="solid"/>
-                      <a:round/>
-                      <a:headEnd type="none" w="med" len="med"/>
-                      <a:tailEnd type="none" w="med" len="med"/>
-                    </a:lnB>
-                    <a:solidFill>
-                      <a:srgbClr val="FFFFFF"/>
-                    </a:solidFill>
-                  </a:tcPr>
-                </a:tc>
-                <a:tc>
-                  <a:txBody>
-                    <a:bodyPr/>
-                    <a:lstStyle/>
-                    <a:p>
-                      <a:pPr algn="ctr" indent="0" marL="0">
-                        <a:buNone/>
-                      </a:pPr>
-                      <a:r>
-                        <a:rPr lang="en-US" sz="1400" b="1" dirty="0">
-                          <a:solidFill>
-                            <a:srgbClr val="2F7A4F"/>
-                          </a:solidFill>
-                          <a:latin typeface="Calibri" pitchFamily="34" charset="0"/>
-                          <a:ea typeface="Calibri" pitchFamily="34" charset="-122"/>
-                          <a:cs typeface="Calibri" pitchFamily="34" charset="-120"/>
-                        </a:rPr>
-                        <a:t>10/10</a:t>
-                      </a:r>
-                      <a:endParaRPr lang="en-US" sz="1400" dirty="0">
-                        <a:latin typeface="Calibri" charset="0"/>
-                        <a:ea typeface="Calibri" charset="0"/>
-                        <a:cs typeface="Calibri" charset="0"/>
-                      </a:endParaRPr>
-                    </a:p>
-                  </a:txBody>
-                  <a:tcPr marL="91440" marR="91440" marT="45720" marB="45720">
-                    <a:lnL w="9525" cap="flat" cmpd="sng" algn="ctr">
-                      <a:solidFill>
-                        <a:srgbClr val="D5DCD9"/>
-                      </a:solidFill>
-                      <a:prstDash val="solid"/>
-                      <a:round/>
-                      <a:headEnd type="none" w="med" len="med"/>
-                      <a:tailEnd type="none" w="med" len="med"/>
-                    </a:lnL>
-                    <a:lnR w="9525" cap="flat" cmpd="sng" algn="ctr">
-                      <a:solidFill>
-                        <a:srgbClr val="D5DCD9"/>
-                      </a:solidFill>
-                      <a:prstDash val="solid"/>
-                      <a:round/>
-                      <a:headEnd type="none" w="med" len="med"/>
-                      <a:tailEnd type="none" w="med" len="med"/>
-                    </a:lnR>
-                    <a:lnT w="9525" cap="flat" cmpd="sng" algn="ctr">
-                      <a:solidFill>
-                        <a:srgbClr val="D5DCD9"/>
-                      </a:solidFill>
-                      <a:prstDash val="solid"/>
-                      <a:round/>
-                      <a:headEnd type="none" w="med" len="med"/>
-                      <a:tailEnd type="none" w="med" len="med"/>
-                    </a:lnT>
-                    <a:lnB w="9525" cap="flat" cmpd="sng" algn="ctr">
-                      <a:solidFill>
-                        <a:srgbClr val="D5DCD9"/>
-                      </a:solidFill>
-                      <a:prstDash val="solid"/>
-                      <a:round/>
-                      <a:headEnd type="none" w="med" len="med"/>
-                      <a:tailEnd type="none" w="med" len="med"/>
-                    </a:lnB>
-                    <a:solidFill>
-                      <a:srgbClr val="FFFFFF"/>
-                    </a:solidFill>
-                  </a:tcPr>
-                </a:tc>
-                <a:tc>
-                  <a:txBody>
-                    <a:bodyPr/>
-                    <a:lstStyle/>
-                    <a:p>
-                      <a:pPr algn="ctr" indent="0" marL="0">
-                        <a:buNone/>
-                      </a:pPr>
-                      <a:r>
-                        <a:rPr lang="en-US" sz="1400" dirty="0">
-                          <a:solidFill>
-                            <a:srgbClr val="1B2220"/>
-                          </a:solidFill>
-                          <a:latin typeface="Calibri" pitchFamily="34" charset="0"/>
-                          <a:ea typeface="Calibri" pitchFamily="34" charset="-122"/>
-                          <a:cs typeface="Calibri" pitchFamily="34" charset="-120"/>
-                        </a:rPr>
-                        <a:t>10/10</a:t>
-                      </a:r>
-                      <a:endParaRPr lang="en-US" sz="1400" dirty="0">
-                        <a:latin typeface="Calibri" charset="0"/>
-                        <a:ea typeface="Calibri" charset="0"/>
-                        <a:cs typeface="Calibri" charset="0"/>
-                      </a:endParaRPr>
-                    </a:p>
-                  </a:txBody>
-                  <a:tcPr marL="91440" marR="91440" marT="45720" marB="45720">
-                    <a:lnL w="9525" cap="flat" cmpd="sng" algn="ctr">
-                      <a:solidFill>
-                        <a:srgbClr val="D5DCD9"/>
-                      </a:solidFill>
-                      <a:prstDash val="solid"/>
-                      <a:round/>
-                      <a:headEnd type="none" w="med" len="med"/>
-                      <a:tailEnd type="none" w="med" len="med"/>
-                    </a:lnL>
-                    <a:lnR w="9525" cap="flat" cmpd="sng" algn="ctr">
-                      <a:solidFill>
-                        <a:srgbClr val="D5DCD9"/>
-                      </a:solidFill>
-                      <a:prstDash val="solid"/>
-                      <a:round/>
-                      <a:headEnd type="none" w="med" len="med"/>
-                      <a:tailEnd type="none" w="med" len="med"/>
-                    </a:lnR>
-                    <a:lnT w="9525" cap="flat" cmpd="sng" algn="ctr">
-                      <a:solidFill>
-                        <a:srgbClr val="D5DCD9"/>
-                      </a:solidFill>
-                      <a:prstDash val="solid"/>
-                      <a:round/>
-                      <a:headEnd type="none" w="med" len="med"/>
-                      <a:tailEnd type="none" w="med" len="med"/>
-                    </a:lnT>
-                    <a:lnB w="9525" cap="flat" cmpd="sng" algn="ctr">
-                      <a:solidFill>
-                        <a:srgbClr val="D5DCD9"/>
-                      </a:solidFill>
-                      <a:prstDash val="solid"/>
-                      <a:round/>
-                      <a:headEnd type="none" w="med" len="med"/>
-                      <a:tailEnd type="none" w="med" len="med"/>
-                    </a:lnB>
-                    <a:solidFill>
-                      <a:srgbClr val="FFFFFF"/>
-                    </a:solidFill>
-                  </a:tcPr>
-                </a:tc>
-                <a:tc>
-                  <a:txBody>
-                    <a:bodyPr/>
-                    <a:lstStyle/>
-                    <a:p>
-                      <a:pPr algn="ctr" indent="0" marL="0">
-                        <a:buNone/>
-                      </a:pPr>
-                      <a:r>
-                        <a:rPr lang="en-US" sz="1400" dirty="0">
-                          <a:solidFill>
-                            <a:srgbClr val="1B2220"/>
-                          </a:solidFill>
-                          <a:latin typeface="Calibri" pitchFamily="34" charset="0"/>
-                          <a:ea typeface="Calibri" pitchFamily="34" charset="-122"/>
-                          <a:cs typeface="Calibri" pitchFamily="34" charset="-120"/>
-                        </a:rPr>
-                        <a:t>7/10</a:t>
-                      </a:r>
-                      <a:endParaRPr lang="en-US" sz="1400" dirty="0">
-                        <a:latin typeface="Calibri" charset="0"/>
-                        <a:ea typeface="Calibri" charset="0"/>
-                        <a:cs typeface="Calibri" charset="0"/>
-                      </a:endParaRPr>
-                    </a:p>
-                  </a:txBody>
-                  <a:tcPr marL="91440" marR="91440" marT="45720" marB="45720">
-                    <a:lnL w="9525" cap="flat" cmpd="sng" algn="ctr">
-                      <a:solidFill>
-                        <a:srgbClr val="D5DCD9"/>
-                      </a:solidFill>
-                      <a:prstDash val="solid"/>
-                      <a:round/>
-                      <a:headEnd type="none" w="med" len="med"/>
-                      <a:tailEnd type="none" w="med" len="med"/>
-                    </a:lnL>
-                    <a:lnR w="9525" cap="flat" cmpd="sng" algn="ctr">
-                      <a:solidFill>
-                        <a:srgbClr val="D5DCD9"/>
-                      </a:solidFill>
-                      <a:prstDash val="solid"/>
-                      <a:round/>
-                      <a:headEnd type="none" w="med" len="med"/>
-                      <a:tailEnd type="none" w="med" len="med"/>
-                    </a:lnR>
-                    <a:lnT w="9525" cap="flat" cmpd="sng" algn="ctr">
-                      <a:solidFill>
-                        <a:srgbClr val="D5DCD9"/>
-                      </a:solidFill>
-                      <a:prstDash val="solid"/>
-                      <a:round/>
-                      <a:headEnd type="none" w="med" len="med"/>
-                      <a:tailEnd type="none" w="med" len="med"/>
-                    </a:lnT>
-                    <a:lnB w="9525" cap="flat" cmpd="sng" algn="ctr">
-                      <a:solidFill>
-                        <a:srgbClr val="D5DCD9"/>
-                      </a:solidFill>
-                      <a:prstDash val="solid"/>
-                      <a:round/>
-                      <a:headEnd type="none" w="med" len="med"/>
-                      <a:tailEnd type="none" w="med" len="med"/>
-                    </a:lnB>
-                    <a:solidFill>
-                      <a:srgbClr val="FFFFFF"/>
-                    </a:solidFill>
-                  </a:tcPr>
-                </a:tc>
-              </a:tr>
-              <a:tr h="457200">
+              <a:tr h="402336">
                 <a:tc>
                   <a:txBody>
                     <a:bodyPr/>
@@ -6605,7 +6892,7 @@
                           <a:ea typeface="Calibri" pitchFamily="34" charset="-122"/>
                           <a:cs typeface="Calibri" pitchFamily="34" charset="-120"/>
                         </a:rPr>
-                        <a:t>4/10</a:t>
+                        <a:t>0/10</a:t>
                       </a:r>
                       <a:endParaRPr lang="en-US" sz="1400" dirty="0">
                         <a:latin typeface="Calibri" charset="0"/>
@@ -6673,7 +6960,7 @@
                           <a:ea typeface="Calibri" pitchFamily="34" charset="-122"/>
                           <a:cs typeface="Calibri" pitchFamily="34" charset="-120"/>
                         </a:rPr>
-                        <a:t>6/10</a:t>
+                        <a:t>0/10 (2.3 stages scripted per run)</a:t>
                       </a:r>
                       <a:endParaRPr lang="en-US" sz="1400" dirty="0">
                         <a:latin typeface="Calibri" charset="0"/>
@@ -6762,7 +7049,7 @@
                 <a:ea typeface="Calibri" pitchFamily="34" charset="-122"/>
                 <a:cs typeface="Calibri" pitchFamily="34" charset="-120"/>
               </a:rPr>
-              <a:t>Spoon: grasped in 10/10 seeds, set down 3.3–4.6 cm from target (pass line 3 cm). Pour: failed seeds stop at ~47° tilt.</a:t>
+              <a:t>Policy (120k steps): plate, drawer + mug, fork 8-10/10. From a scripted start: pour 3/10 (84% of the water in, but &gt;2 beads spilled), bottle back 10/10, hand-over 5/10. Chained, those states drift and script takeovers knock placed items, so no run sets the whole table.</a:t>
             </a:r>
             <a:endParaRPr lang="en-US" sz="1300" dirty="0"/>
           </a:p>
@@ -6777,11 +7064,11 @@
         <p:spPr>
           <a:xfrm>
             <a:off x="7955280" y="1463040"/>
-            <a:ext cx="3685032" cy="3328416"/>
+            <a:ext cx="3685032" cy="5029200"/>
           </a:xfrm>
           <a:prstGeom prst="roundRect">
             <a:avLst>
-              <a:gd name="adj" fmla="val 1648"/>
+              <a:gd name="adj" fmla="val 1489"/>
             </a:avLst>
           </a:prstGeom>
           <a:solidFill>
@@ -6843,7 +7130,7 @@
         <p:spPr>
           <a:xfrm>
             <a:off x="8183880" y="2148840"/>
-            <a:ext cx="3291840" cy="2560320"/>
+            <a:ext cx="3291840" cy="4206240"/>
           </a:xfrm>
           <a:prstGeom prst="rect">
             <a:avLst/>
@@ -6863,7 +7150,7 @@
               <a:buChar char="•"/>
             </a:pPr>
             <a:r>
-              <a:rPr lang="en-US" sz="1400" dirty="0">
+              <a:rPr lang="en-US" sz="1200" dirty="0">
                 <a:solidFill>
                   <a:srgbClr val="1B2220"/>
                 </a:solidFill>
@@ -6871,9 +7158,9 @@
                 <a:ea typeface="Calibri" pitchFamily="34" charset="-122"/>
                 <a:cs typeface="Calibri" pitchFamily="34" charset="-120"/>
               </a:rPr>
-              <a:t>Grasps are constraint-assisted, not finger-contact</a:t>
-            </a:r>
-            <a:endParaRPr lang="en-US" sz="1400" dirty="0"/>
+              <a:t>Gripper capped at the stock servo's sustainable 0.8 N·m with μ 0.8 pads (Menagerie's default is 12 V stall torque, μ 1); props are child-tableware scale</a:t>
+            </a:r>
+            <a:endParaRPr lang="en-US" sz="1200" dirty="0"/>
           </a:p>
           <a:p>
             <a:pPr marL="342900" indent="-342900">
@@ -6884,7 +7171,7 @@
               <a:buChar char="•"/>
             </a:pPr>
             <a:r>
-              <a:rPr lang="en-US" sz="1400" dirty="0">
+              <a:rPr lang="en-US" sz="1200" dirty="0">
                 <a:solidFill>
                   <a:srgbClr val="1B2220"/>
                 </a:solidFill>
@@ -6892,9 +7179,9 @@
                 <a:ea typeface="Calibri" pitchFamily="34" charset="-122"/>
                 <a:cs typeface="Calibri" pitchFamily="34" charset="-120"/>
               </a:rPr>
-              <a:t>Hybrid stages finished by a script are counted as assisted, never as policy wins</a:t>
-            </a:r>
-            <a:endParaRPr lang="en-US" sz="1400" dirty="0"/>
+              <a:t>Seeds 0–9 are the seeds the scripted skills were tuned on (seed 0 unrandomised); 30 unseen seeds are reported next to them</a:t>
+            </a:r>
+            <a:endParaRPr lang="en-US" sz="1200" dirty="0"/>
           </a:p>
           <a:p>
             <a:pPr marL="342900" indent="-342900">
@@ -6905,7 +7192,7 @@
               <a:buChar char="•"/>
             </a:pPr>
             <a:r>
-              <a:rPr lang="en-US" sz="1400" dirty="0">
+              <a:rPr lang="en-US" sz="1200" dirty="0">
                 <a:solidFill>
                   <a:srgbClr val="1B2220"/>
                 </a:solidFill>
@@ -6913,9 +7200,114 @@
                 <a:ea typeface="Calibri" pitchFamily="34" charset="-122"/>
                 <a:cs typeface="Calibri" pitchFamily="34" charset="-120"/>
               </a:rPr>
+              <a:t>Stage completion is judged from simulator state and the policy is told the current stage</a:t>
+            </a:r>
+            <a:endParaRPr lang="en-US" sz="1200" dirty="0"/>
+          </a:p>
+          <a:p>
+            <a:pPr marL="342900" indent="-342900">
+              <a:spcAft>
+                <a:spcPts val="800"/>
+              </a:spcAft>
+              <a:buSzPct val="100000"/>
+              <a:buChar char="•"/>
+            </a:pPr>
+            <a:r>
+              <a:rPr lang="en-US" sz="1200" dirty="0">
+                <a:solidFill>
+                  <a:srgbClr val="1B2220"/>
+                </a:solidFill>
+                <a:latin typeface="Calibri" pitchFamily="34" charset="0"/>
+                <a:ea typeface="Calibri" pitchFamily="34" charset="-122"/>
+                <a:cs typeface="Calibri" pitchFamily="34" charset="-120"/>
+              </a:rPr>
+              <a:t>The mug stands on the table during the pour — the other hand cannot steady it within reach</a:t>
+            </a:r>
+            <a:endParaRPr lang="en-US" sz="1200" dirty="0"/>
+          </a:p>
+          <a:p>
+            <a:pPr marL="342900" indent="-342900">
+              <a:spcAft>
+                <a:spcPts val="800"/>
+              </a:spcAft>
+              <a:buSzPct val="100000"/>
+              <a:buChar char="•"/>
+            </a:pPr>
+            <a:r>
+              <a:rPr lang="en-US" sz="1200" dirty="0">
+                <a:solidFill>
+                  <a:srgbClr val="1B2220"/>
+                </a:solidFill>
+                <a:latin typeface="Calibri" pitchFamily="34" charset="0"/>
+                <a:ea typeface="Calibri" pitchFamily="34" charset="-122"/>
+                <a:cs typeface="Calibri" pitchFamily="34" charset="-120"/>
+              </a:rPr>
+              <a:t>Water is 24 small beads, not a fluid</a:t>
+            </a:r>
+            <a:endParaRPr lang="en-US" sz="1200" dirty="0"/>
+          </a:p>
+          <a:p>
+            <a:pPr marL="342900" indent="-342900">
+              <a:spcAft>
+                <a:spcPts val="800"/>
+              </a:spcAft>
+              <a:buSzPct val="100000"/>
+              <a:buChar char="•"/>
+            </a:pPr>
+            <a:r>
+              <a:rPr lang="en-US" sz="1200" dirty="0">
+                <a:solidFill>
+                  <a:srgbClr val="1B2220"/>
+                </a:solidFill>
+                <a:latin typeface="Calibri" pitchFamily="34" charset="0"/>
+                <a:ea typeface="Calibri" pitchFamily="34" charset="-122"/>
+                <a:cs typeface="Calibri" pitchFamily="34" charset="-120"/>
+              </a:rPr>
+              <a:t>Hybrid: stages a script had to finish are counted as assisted, never as policy wins</a:t>
+            </a:r>
+            <a:endParaRPr lang="en-US" sz="1200" dirty="0"/>
+          </a:p>
+          <a:p>
+            <a:pPr marL="342900" indent="-342900">
+              <a:spcAft>
+                <a:spcPts val="800"/>
+              </a:spcAft>
+              <a:buSzPct val="100000"/>
+              <a:buChar char="•"/>
+            </a:pPr>
+            <a:r>
+              <a:rPr lang="en-US" sz="1200" dirty="0">
+                <a:solidFill>
+                  <a:srgbClr val="1B2220"/>
+                </a:solidFill>
+                <a:latin typeface="Calibri" pitchFamily="34" charset="0"/>
+                <a:ea typeface="Calibri" pitchFamily="34" charset="-122"/>
+                <a:cs typeface="Calibri" pitchFamily="34" charset="-120"/>
+              </a:rPr>
+              <a:t>Demo video: pour, bottle return and hand-over are run by the scripted skills, labelled on screen</a:t>
+            </a:r>
+            <a:endParaRPr lang="en-US" sz="1200" dirty="0"/>
+          </a:p>
+          <a:p>
+            <a:pPr marL="342900" indent="-342900">
+              <a:spcAft>
+                <a:spcPts val="800"/>
+              </a:spcAft>
+              <a:buSzPct val="100000"/>
+              <a:buChar char="•"/>
+            </a:pPr>
+            <a:r>
+              <a:rPr lang="en-US" sz="1200" dirty="0">
+                <a:solidFill>
+                  <a:srgbClr val="1B2220"/>
+                </a:solidFill>
+                <a:latin typeface="Calibri" pitchFamily="34" charset="0"/>
+                <a:ea typeface="Calibri" pitchFamily="34" charset="-122"/>
+                <a:cs typeface="Calibri" pitchFamily="34" charset="-120"/>
+              </a:rPr>
               <a:t>Benchmarked on Core i9 + iGPU; Core Ultra run is one command</a:t>
             </a:r>
-            <a:endParaRPr lang="en-US" sz="1400" dirty="0"/>
+            <a:endParaRPr lang="en-US" sz="1200" dirty="0"/>
           </a:p>
         </p:txBody>
       </p:sp>
@@ -7048,7 +7440,7 @@
                 <a:ea typeface="Cambria" pitchFamily="34" charset="-122"/>
                 <a:cs typeface="Cambria" pitchFamily="34" charset="-120"/>
               </a:rPr>
-              <a:t>Contact-rich grasping</a:t>
+              <a:t>Harder contact skills</a:t>
             </a:r>
             <a:endParaRPr lang="en-US" sz="2000" dirty="0"/>
           </a:p>
@@ -7087,7 +7479,7 @@
                 <a:ea typeface="Calibri" pitchFamily="34" charset="-122"/>
                 <a:cs typeface="Calibri" pitchFamily="34" charset="-120"/>
               </a:rPr>
-              <a:t>Replace the attach constraint with finger contact and train on it</a:t>
+              <a:t>Particle-fluid pouring and full-size cutlery with the same contact-only physics</a:t>
             </a:r>
             <a:endParaRPr lang="en-US" sz="1500" dirty="0"/>
           </a:p>

</xml_diff>